<commit_message>
presentation: remove the rakes slide, the run-recording button and video, the unsigned-chain and 57% rows
</commit_message>
<xml_diff>
--- a/presentation/OSreboot.pptx
+++ b/presentation/OSreboot.pptx
@@ -22,7 +22,6 @@
     <p:sldId id="270" r:id="rId16"/>
     <p:sldId id="271" r:id="rId17"/>
     <p:sldId id="272" r:id="rId18"/>
-    <p:sldId id="273" r:id="rId19"/>
     <p:sldId id="274" r:id="rId20"/>
     <p:sldId id="275" r:id="rId21"/>
     <p:sldId id="276" r:id="rId22"/>
@@ -1594,17 +1593,39 @@
           <a:lstStyle/>
           <a:p>
             <a:r>
-              <a:rPr lang="ru-RU" dirty="0"/>
-              <a:t>ВРЕМЯ: 0:45 · по плану закончить к 9:40
-ГЛАВНОЕ: ответ В. Две загрузки машины — 57 % простоя.
-• Пройди по шкале сверху вниз: сброс и прошивка до iPXE — 24 с; скачивание среды — 15; старт Linux в памяти — 28; образы — 42; проверка и запись — 13; перезагрузка до сигнала — 42.
-• «Загрузки машины — 94,5 с, больше половины. Скачивание — 57 с, треть. Проверка и запись — 13 с».
-• Вывод: «Быстрый интернет даст меньше, чем кажется. Ускорять нужно загрузки: меньший образ среды восстановления и kexec вместо второго прохода прошивки».
-• «Скачивание упиралось в 100-мегабитный порт ноутбука: 11 MiB/с — 98 % предела».
-ЗАПАСНОЙ ВАРИАНТ ДЕМО: если на демонстрации подведёт сеть, вернись сюда по ссылке со слайда демо и расскажи прогон по шкале.
-ПЕРЕХОД: «Получилось не с первого раза».</a:t>
-            </a:r>
-            <a:endParaRPr lang="ru-RU" dirty="0"/>
+              <a:t>ВРЕМЯ: 0:45 · по плану закончить к 9:40</a:t>
+            </a:r>
+          </a:p>
+          <a:p/>
+          <a:p>
+            <a:r>
+              <a:t>ГЛАВНОЕ: ответ В. Две загрузки машины — 57 % простоя.</a:t>
+            </a:r>
+          </a:p>
+          <a:p>
+            <a:r>
+              <a:t>• Пройди по шкале сверху вниз: сброс и прошивка до iPXE — 24 с; скачивание среды — 15; старт Linux в памяти — 28; образы — 42; проверка и запись — 13; перезагрузка до сигнала — 42.</a:t>
+            </a:r>
+          </a:p>
+          <a:p>
+            <a:r>
+              <a:t>• «Загрузки машины — 94,5 с, больше половины. Скачивание — 57 с, треть. Проверка и запись — 13 с».</a:t>
+            </a:r>
+          </a:p>
+          <a:p>
+            <a:r>
+              <a:t>• Вывод: «Быстрый интернет даст меньше, чем кажется. Ускорять нужно загрузки: меньший образ среды восстановления и kexec вместо второго прохода прошивки».</a:t>
+            </a:r>
+          </a:p>
+          <a:p>
+            <a:r>
+              <a:t>• «Скачивание упиралось в 100-мегабитный порт ноутбука: 11 MiB/с — 98 % предела».</a:t>
+            </a:r>
+          </a:p>
+          <a:p>
+            <a:r>
+              <a:t>ПЕРЕХОД: «Теперь проверим вживую».</a:t>
+            </a:r>
           </a:p>
         </p:txBody>
       </p:sp>
@@ -1626,101 +1647,6 @@
             <a:fld id="{F7021451-1387-4CA6-816F-3879F97B5CBC}" type="slidenum">
               <a:rPr lang="ru-RU"/>
               <a:t>17</a:t>
-            </a:fld>
-            <a:endParaRPr lang="ru-RU"/>
-          </a:p>
-        </p:txBody>
-      </p:sp>
-    </p:spTree>
-    <p:extLst>
-      <p:ext uri="{BB962C8B-B14F-4D97-AF65-F5344CB8AC3E}">
-        <p14:creationId xmlns:p14="http://schemas.microsoft.com/office/powerpoint/2010/main" val="1024086991"/>
-      </p:ext>
-    </p:extLst>
-  </p:cSld>
-  <p:clrMapOvr>
-    <a:masterClrMapping/>
-  </p:clrMapOvr>
-</p:notes>
-</file>
-
-<file path=ppt/notesSlides/notesSlide18.xml><?xml version="1.0" encoding="utf-8"?>
-<p:notes xmlns:a="http://schemas.openxmlformats.org/drawingml/2006/main" xmlns:r="http://schemas.openxmlformats.org/officeDocument/2006/relationships" xmlns:p="http://schemas.openxmlformats.org/presentationml/2006/main">
-  <p:cSld>
-    <p:spTree>
-      <p:nvGrpSpPr>
-        <p:cNvPr id="1" name=""/>
-        <p:cNvGrpSpPr/>
-        <p:nvPr/>
-      </p:nvGrpSpPr>
-      <p:grpSpPr>
-        <a:xfrm>
-          <a:off x="0" y="0"/>
-          <a:ext cx="0" cy="0"/>
-          <a:chOff x="0" y="0"/>
-          <a:chExt cx="0" cy="0"/>
-        </a:xfrm>
-      </p:grpSpPr>
-      <p:sp>
-        <p:nvSpPr>
-          <p:cNvPr id="2" name="Slide Image Placeholder 1"/>
-          <p:cNvSpPr>
-            <a:spLocks noGrp="1" noRot="1" noChangeAspect="1"/>
-          </p:cNvSpPr>
-          <p:nvPr>
-            <p:ph type="sldImg"/>
-          </p:nvPr>
-        </p:nvSpPr>
-        <p:spPr/>
-      </p:sp>
-      <p:sp>
-        <p:nvSpPr>
-          <p:cNvPr id="3" name="Notes Placeholder 2"/>
-          <p:cNvSpPr>
-            <a:spLocks noGrp="1"/>
-          </p:cNvSpPr>
-          <p:nvPr>
-            <p:ph type="body" idx="1"/>
-          </p:nvPr>
-        </p:nvSpPr>
-        <p:spPr/>
-        <p:txBody>
-          <a:bodyPr/>
-          <a:lstStyle/>
-          <a:p>
-            <a:r>
-              <a:rPr lang="ru-RU" dirty="0"/>
-              <a:t>ВРЕМЯ: 0:45 · по плану закончить к 10:25
-ГЛАВНОЕ: 2–3 истории, коротко. Слайд можно пропустить и рассказать эти истории во время демо, пока идёт сетевая загрузка.
-• Прошивка удаляла запись с адресом сервера — поэтому iPXE лежит на диске.
-• BootNext дважды загрузил старую систему: прошивка Insyde записала свою запись под нужным номером. Перешёл на одноразовую запись systemd-boot.
-• Домашний роутер отвечал на DNS ошибкой — повторы и публичные DNS-серверы.
-• После сброса старая SSH-сессия часами держала порт — туннель через Unix-сокет.
-ЕЩЁ (если спросят): snponly.efi не видел сетевую карту — собрал полный ipxe.efi с собственными драйверами.
-ПЕРЕХОД: «Хватит слов — давайте сотрём систему».</a:t>
-            </a:r>
-            <a:endParaRPr lang="ru-RU" dirty="0"/>
-          </a:p>
-        </p:txBody>
-      </p:sp>
-      <p:sp>
-        <p:nvSpPr>
-          <p:cNvPr id="4" name="Slide Number Placeholder 3"/>
-          <p:cNvSpPr>
-            <a:spLocks noGrp="1"/>
-          </p:cNvSpPr>
-          <p:nvPr>
-            <p:ph type="sldNum" sz="quarter" idx="10"/>
-          </p:nvPr>
-        </p:nvSpPr>
-        <p:spPr/>
-        <p:txBody>
-          <a:bodyPr/>
-          <a:lstStyle/>
-          <a:p>
-            <a:fld id="{F7021451-1387-4CA6-816F-3879F97B5CBC}" type="slidenum">
-              <a:rPr lang="ru-RU"/>
-              <a:t>18</a:t>
             </a:fld>
             <a:endParaRPr lang="ru-RU"/>
           </a:p>
@@ -1784,27 +1710,94 @@
           <a:lstStyle/>
           <a:p>
             <a:r>
-              <a:rPr lang="ru-RU" dirty="0"/>
-              <a:t>ВРЕМЯ: 4:00 · по плану закончить к 14:25
-ПЕРЕД СТАРТОМ:
-• QR на экране 10 секунд: «Откройте на телефоне — увидите то же, что и я».
-• На странице ноутбук «на связи», сигнал приходит раз в секунду.
-• На ноутбуке: osreboot-wipe без --apply — проверки проходят.
-• Посмотри на часы и нажми Enter: osreboot-wipe --apply. Переключи экран на страницу состояния.
-ЧТО ГОВОРИТЬ (секунды от Enter):
-0 — «Скрипт поставил одноразовую запись iPXE, остановил сигналы, затёр по 64 MiB и сбросил машину. Системы больше нет».
-0–24 — пустое время: расскажи, почему iPXE лежит на диске (история про прошивку, слайд «Что пошло не по плану»).
-24 — «iPXE нашёл сервер и качает среду восстановления по HTTPS, 132 MiB».
-40 — «Стартует Linux целиком в памяти, около 28 секунд».
-69 — «Среда восстановления отчиталась и нашла разделы. Качаются образы, 405 MiB, около 11 MiB/с».
-111 — «Проверка SHA-256: не совпадёт хоть один байт — ничего не запишется».
-116 — «Запись, чтение обратно и сверка, потом BootNext».
-124 — «Перезагрузка в восстановленную систему. Ждём первый сигнал с новым boot ID».
-≈166 — «Вот он! Смотрим цифру простоя на странице. Строка с этапами записалась в outages.csv».
-ЕСЛИ СЕТЬ МЕДЛЕННЕЕ: скачивание растянется — комментируй проценты на странице.
-ЕСЛИ СЛОМАЛОСЬ: «Сработал предохранитель: через 60 секунд или 20 минут машина сама вернётся в свою систему». Нажми кнопку внизу слайда — откроется слайд 17 с записью прогона — или включи запасное видео.</a:t>
-            </a:r>
-            <a:endParaRPr lang="ru-RU" dirty="0"/>
+              <a:t>ВРЕМЯ: 4:00 · по плану закончить к 13:40</a:t>
+            </a:r>
+          </a:p>
+          <a:p/>
+          <a:p>
+            <a:r>
+              <a:t>ПЕРЕД СТАРТОМ:</a:t>
+            </a:r>
+          </a:p>
+          <a:p>
+            <a:r>
+              <a:t>• QR на экране 10 секунд: «Откройте на телефоне — увидите то же, что и я».</a:t>
+            </a:r>
+          </a:p>
+          <a:p>
+            <a:r>
+              <a:t>• На странице ноутбук «на связи», сигнал приходит раз в секунду.</a:t>
+            </a:r>
+          </a:p>
+          <a:p>
+            <a:r>
+              <a:t>• На ноутбуке: osreboot-wipe без --apply — проверки проходят.</a:t>
+            </a:r>
+          </a:p>
+          <a:p>
+            <a:r>
+              <a:t>• Посмотри на часы и нажми Enter: osreboot-wipe --apply. Переключи экран на страницу состояния.</a:t>
+            </a:r>
+          </a:p>
+          <a:p>
+            <a:r>
+              <a:t>ЧТО ГОВОРИТЬ (секунды от Enter):</a:t>
+            </a:r>
+          </a:p>
+          <a:p>
+            <a:r>
+              <a:t>0 — «Скрипт поставил одноразовую запись iPXE, остановил сигналы, затёр по 64 MiB и сбросил машину. Системы больше нет».</a:t>
+            </a:r>
+          </a:p>
+          <a:p>
+            <a:r>
+              <a:t>0–24 — пустое время: расскажи, почему iPXE лежит на диске (прошивка удаляет запись с адресом сервера).</a:t>
+            </a:r>
+          </a:p>
+          <a:p>
+            <a:r>
+              <a:t>24 — «iPXE нашёл сервер и качает среду восстановления по HTTPS, 132 MiB».</a:t>
+            </a:r>
+          </a:p>
+          <a:p>
+            <a:r>
+              <a:t>40 — «Стартует Linux целиком в памяти, около 28 секунд».</a:t>
+            </a:r>
+          </a:p>
+          <a:p>
+            <a:r>
+              <a:t>69 — «Среда восстановления отчиталась и нашла разделы. Качаются образы, 405 MiB, около 11 MiB/с».</a:t>
+            </a:r>
+          </a:p>
+          <a:p>
+            <a:r>
+              <a:t>111 — «Проверка SHA-256: не совпадёт хоть один байт — ничего не запишется».</a:t>
+            </a:r>
+          </a:p>
+          <a:p>
+            <a:r>
+              <a:t>116 — «Запись, чтение обратно и сверка, потом BootNext».</a:t>
+            </a:r>
+          </a:p>
+          <a:p>
+            <a:r>
+              <a:t>124 — «Перезагрузка в восстановленную систему. Ждём первый сигнал с новым boot ID».</a:t>
+            </a:r>
+          </a:p>
+          <a:p>
+            <a:r>
+              <a:t>≈166 — «Вот он! Смотрим цифру простоя на странице. Строка с этапами записалась в outages.csv».</a:t>
+            </a:r>
+          </a:p>
+          <a:p>
+            <a:r>
+              <a:t>ЕСЛИ СЕТЬ МЕДЛЕННЕЕ: скачивание растянется — комментируй проценты на странице.</a:t>
+            </a:r>
+          </a:p>
+          <a:p>
+            <a:r>
+              <a:t>ЕСЛИ СЛОМАЛОСЬ: «Сработал предохранитель: через 60 секунд или 20 минут машина сама вернётся в свою систему».</a:t>
+            </a:r>
           </a:p>
         </p:txBody>
       </p:sp>
@@ -1980,15 +1973,29 @@
           <a:lstStyle/>
           <a:p>
             <a:r>
-              <a:rPr lang="ru-RU" dirty="0"/>
-              <a:t>ВРЕМЯ: 0:40 · по плану закончить к 15:05
-СПРОСИ (по желанию): «Что будет, если стереть весь диск целиком?» → «iPXE пропадёт, и цепочка оборвётся. Это главное ограничение».
-• Пройди по строкам: слева ограничение, справа — что с ним делать.
-• Особо: «Запускает восстановление команда затирания. Настоящую поломку должен ловить счётчик неудачных загрузок в systemd-boot».
-• «Цепочка не подписана: кто управляет сервером, тот управляет восстановлением. Следующий шаг — подпись и Secure Boot».
-ПЕРЕХОД: «Итоги».</a:t>
-            </a:r>
-            <a:endParaRPr lang="ru-RU" dirty="0"/>
+              <a:t>ВРЕМЯ: 0:40 · по плану закончить к 14:20</a:t>
+            </a:r>
+          </a:p>
+          <a:p/>
+          <a:p>
+            <a:r>
+              <a:t>СПРОСИ (по желанию): «Что будет, если стереть весь диск целиком?» → «iPXE пропадёт, и цепочка оборвётся. Это главное ограничение».</a:t>
+            </a:r>
+          </a:p>
+          <a:p>
+            <a:r>
+              <a:t>• Пройди по строкам: слева ограничение, справа — что с ним делать.</a:t>
+            </a:r>
+          </a:p>
+          <a:p>
+            <a:r>
+              <a:t>• Особо: «Запускает восстановление команда затирания. Настоящую поломку должен ловить счётчик неудачных загрузок в systemd-boot».</a:t>
+            </a:r>
+          </a:p>
+          <a:p>
+            <a:r>
+              <a:t>ПЕРЕХОД: «Итоги».</a:t>
+            </a:r>
           </a:p>
         </p:txBody>
       </p:sp>
@@ -2073,13 +2080,24 @@
           <a:lstStyle/>
           <a:p>
             <a:r>
-              <a:rPr lang="ru-RU" dirty="0"/>
-              <a:t>ВРЕМЯ: 0:25 · по плану закончить к 15:30
-• «Помните первый вопрос? Вариант В — починить удалённо — теперь есть и у ноутбука без BMC».
-• Три пункта: работает; около 165 секунд, больше половины — загрузки; открыто и измеримо.
-• «Спасибо за внимание! Готов ответить на вопросы».</a:t>
-            </a:r>
-            <a:endParaRPr lang="ru-RU" dirty="0"/>
+              <a:t>ВРЕМЯ: 0:25 · по плану закончить к 14:45</a:t>
+            </a:r>
+          </a:p>
+          <a:p/>
+          <a:p>
+            <a:r>
+              <a:t>• «Помните первый вопрос? Вариант В — починить удалённо — теперь есть и у ноутбука без BMC».</a:t>
+            </a:r>
+          </a:p>
+          <a:p>
+            <a:r>
+              <a:t>• Три пункта: работает; около 165 секунд, больше половины — загрузки; открыто и измеримо.</a:t>
+            </a:r>
+          </a:p>
+          <a:p>
+            <a:r>
+              <a:t>• «Спасибо за внимание! Готов ответить на вопросы».</a:t>
+            </a:r>
           </a:p>
         </p:txBody>
       </p:sp>
@@ -2164,18 +2182,49 @@
           <a:lstStyle/>
           <a:p>
             <a:r>
-              <a:rPr lang="ru-RU" dirty="0"/>
-              <a:t>ВРЕМЯ: сколько понадобится
-• Слева QR-коды: репозиторий и страница состояния.
-• Справа кнопки на запасные слайды: репозиторий, секреты, таблица всех прогонов. На каждом запасном слайде есть кнопка «к вопросам».
-• Не знаешь ответа: «Хороший вопрос. Это я не проверял; проверил бы так: …».
-ЧАСТЫЕ ВОПРОСЫ:
-• Сколько прогонов? — 6 полных прогонов среды восстановления, из них 4 со стиранием.
-• Что если VPS недоступен? — iPXE не скачает boot.ipxe и через 60 с перезагрузит машину; одноразовая запись уже израсходована, поэтому загрузится основная система.
-• Почему не BootNext? — прошивка дважды подменила запись; одноразовая запись systemd-boot надёжнее.
-• Чем это лучше переустановки с флешки? — не нужен человек рядом, и простой измерен.</a:t>
-            </a:r>
-            <a:endParaRPr lang="ru-RU" dirty="0"/>
+              <a:t>ВРЕМЯ: сколько понадобится</a:t>
+            </a:r>
+          </a:p>
+          <a:p/>
+          <a:p>
+            <a:r>
+              <a:t>• Слева QR-коды: репозиторий и страница состояния.</a:t>
+            </a:r>
+          </a:p>
+          <a:p>
+            <a:r>
+              <a:t>• Справа кнопки на запасные слайды: репозиторий, секреты, таблица всех прогонов. На каждом запасном слайде есть кнопка «к вопросам».</a:t>
+            </a:r>
+          </a:p>
+          <a:p>
+            <a:r>
+              <a:t>• Не знаешь ответа: «Хороший вопрос. Это я не проверял; проверил бы так: …».</a:t>
+            </a:r>
+          </a:p>
+          <a:p>
+            <a:r>
+              <a:t>ЧАСТЫЕ ВОПРОСЫ:</a:t>
+            </a:r>
+          </a:p>
+          <a:p>
+            <a:r>
+              <a:t>• Сколько прогонов? — 6 полных прогонов среды восстановления, из них 4 со стиранием.</a:t>
+            </a:r>
+          </a:p>
+          <a:p>
+            <a:r>
+              <a:t>• Что если VPS недоступен? — iPXE не скачает boot.ipxe и через 60 с перезагрузит машину; одноразовая запись уже израсходована, поэтому загрузится основная система.</a:t>
+            </a:r>
+          </a:p>
+          <a:p>
+            <a:r>
+              <a:t>• Почему не BootNext? — прошивка дважды подменила запись; одноразовая запись systemd-boot надёжнее.</a:t>
+            </a:r>
+          </a:p>
+          <a:p>
+            <a:r>
+              <a:t>• Чем это лучше переустановки с флешки? — не нужен человек рядом, и простой измерен.</a:t>
+            </a:r>
           </a:p>
         </p:txBody>
       </p:sp>
@@ -2260,11 +2309,14 @@
           <a:lstStyle/>
           <a:p>
             <a:r>
-              <a:rPr lang="ru-RU" dirty="0"/>
-              <a:t>ВРЕМЯ: сколько понадобится
-Покажи нужную папку и одной фразой скажи, что в ней. Подробности — в README, раздел «Приложение. Как запустить».</a:t>
-            </a:r>
-            <a:endParaRPr lang="ru-RU" dirty="0"/>
+              <a:t>ВРЕМЯ: сколько понадобится</a:t>
+            </a:r>
+          </a:p>
+          <a:p/>
+          <a:p>
+            <a:r>
+              <a:t>Покажи нужную папку и одной фразой скажи, что в ней. Подробности — в README, раздел «Приложение. Как запустить».</a:t>
+            </a:r>
           </a:p>
         </p:txBody>
       </p:sp>
@@ -2349,11 +2401,14 @@
           <a:lstStyle/>
           <a:p>
             <a:r>
-              <a:rPr lang="ru-RU" dirty="0"/>
-              <a:t>ВРЕМЯ: сколько понадобится
-Веди по шагам 1→6. Главная мысль: открытым токен есть только при создании и в памяти во время работы; сервер хранит только хеш.</a:t>
-            </a:r>
-            <a:endParaRPr lang="ru-RU" dirty="0"/>
+              <a:t>ВРЕМЯ: сколько понадобится</a:t>
+            </a:r>
+          </a:p>
+          <a:p/>
+          <a:p>
+            <a:r>
+              <a:t>Веди по шагам 1→6. Главная мысль: открытым токен есть только при создании и в памяти во время работы; сервер хранит только хеш.</a:t>
+            </a:r>
           </a:p>
         </p:txBody>
       </p:sp>
@@ -2438,11 +2493,14 @@
           <a:lstStyle/>
           <a:p>
             <a:r>
-              <a:rPr lang="ru-RU" dirty="0"/>
-              <a:t>ВРЕМЯ: сколько понадобится
-Покажи, что разброс маленький: среда восстановления 54,0–57,1 с, весь простой 164,0–165,7 с. Прерванный прогон — честно: канал до VPS тогда упал до 0,25 MiB/s.</a:t>
-            </a:r>
-            <a:endParaRPr lang="ru-RU" dirty="0"/>
+              <a:t>ВРЕМЯ: сколько понадобится</a:t>
+            </a:r>
+          </a:p>
+          <a:p/>
+          <a:p>
+            <a:r>
+              <a:t>Покажи, что разброс маленький: среда восстановления 54,0–57,1 с, весь простой 164,0–165,7 с. Прерванный прогон — честно: канал до VPS тогда упал до 0,25 MiB/s.</a:t>
+            </a:r>
           </a:p>
         </p:txBody>
       </p:sp>
@@ -13039,883 +13097,6 @@
 </p:sld>
 </file>
 
-<file path=ppt/slides/slide18.xml><?xml version="1.0" encoding="utf-8"?>
-<p:sld xmlns:a="http://schemas.openxmlformats.org/drawingml/2006/main" xmlns:r="http://schemas.openxmlformats.org/officeDocument/2006/relationships" xmlns:p="http://schemas.openxmlformats.org/presentationml/2006/main">
-  <p:cSld name="Slide 18">
-    <p:spTree>
-      <p:nvGrpSpPr>
-        <p:cNvPr id="1" name=""/>
-        <p:cNvGrpSpPr/>
-        <p:nvPr/>
-      </p:nvGrpSpPr>
-      <p:grpSpPr>
-        <a:xfrm>
-          <a:off x="0" y="0"/>
-          <a:ext cx="0" cy="0"/>
-          <a:chOff x="0" y="0"/>
-          <a:chExt cx="0" cy="0"/>
-        </a:xfrm>
-      </p:grpSpPr>
-      <p:sp>
-        <p:nvSpPr>
-          <p:cNvPr id="2" name="Text 0"/>
-          <p:cNvSpPr/>
-          <p:nvPr>
-            <p:ph idx="100" type="body" hasCustomPrompt="1"/>
-          </p:nvPr>
-        </p:nvSpPr>
-        <p:spPr>
-          <a:xfrm>
-            <a:off x="548640" y="329184"/>
-            <a:ext cx="9144000" cy="310896"/>
-          </a:xfrm>
-          <a:prstGeom prst="rect">
-            <a:avLst/>
-          </a:prstGeom>
-          <a:noFill/>
-          <a:ln/>
-        </p:spPr>
-        <p:txBody>
-          <a:bodyPr wrap="square" lIns="0" tIns="0" rIns="0" bIns="0" rtlCol="0" anchor="ctr"/>
-          <a:lstStyle/>
-          <a:p>
-            <a:pPr indent="0" marL="0">
-              <a:buNone/>
-            </a:pPr>
-            <a:r>
-              <a:rPr lang="ru-RU" sz="1300" b="1" spc="200" kern="0" dirty="0">
-                <a:solidFill>
-                  <a:schemeClr val="accent1"/>
-                </a:solidFill>
-              </a:rPr>
-              <a:t>ГРАБЛИ</a:t>
-            </a:r>
-            <a:endParaRPr lang="ru-RU" sz="1300" dirty="0"/>
-          </a:p>
-        </p:txBody>
-      </p:sp>
-      <p:sp>
-        <p:nvSpPr>
-          <p:cNvPr id="3" name="Text 0"/>
-          <p:cNvSpPr/>
-          <p:nvPr>
-            <p:ph idx="101" type="title" hasCustomPrompt="1"/>
-          </p:nvPr>
-        </p:nvSpPr>
-        <p:spPr>
-          <a:xfrm>
-            <a:off x="548640" y="676656"/>
-            <a:ext cx="11094415" cy="1005840"/>
-          </a:xfrm>
-          <a:prstGeom prst="rect">
-            <a:avLst/>
-          </a:prstGeom>
-          <a:noFill/>
-          <a:ln/>
-        </p:spPr>
-        <p:txBody>
-          <a:bodyPr wrap="square" lIns="0" tIns="0" rIns="0" bIns="0" rtlCol="0" anchor="t"/>
-          <a:lstStyle/>
-          <a:p>
-            <a:pPr algn="l" indent="0" marL="0">
-              <a:buNone/>
-            </a:pPr>
-            <a:r>
-              <a:rPr lang="ru-RU" sz="3400" b="1" dirty="0">
-                <a:solidFill>
-                  <a:schemeClr val="tx1"/>
-                </a:solidFill>
-              </a:rPr>
-              <a:t>Что пошло не по плану</a:t>
-            </a:r>
-            <a:endParaRPr lang="ru-RU" sz="3400" dirty="0"/>
-          </a:p>
-        </p:txBody>
-      </p:sp>
-      <p:sp>
-        <p:nvSpPr>
-          <p:cNvPr id="4" name="Проблема 1"/>
-          <p:cNvSpPr/>
-          <p:nvPr/>
-        </p:nvSpPr>
-        <p:spPr>
-          <a:xfrm>
-            <a:off x="548640" y="1810512"/>
-            <a:ext cx="5410048" cy="2029968"/>
-          </a:xfrm>
-          <a:prstGeom prst="roundRect">
-            <a:avLst>
-              <a:gd name="adj" fmla="val 6306"/>
-            </a:avLst>
-          </a:prstGeom>
-          <a:solidFill>
-            <a:schemeClr val="bg2"/>
-          </a:solidFill>
-          <a:ln/>
-        </p:spPr>
-      </p:sp>
-      <p:sp>
-        <p:nvSpPr>
-          <p:cNvPr id="5" name="Shape 3"/>
-          <p:cNvSpPr/>
-          <p:nvPr/>
-        </p:nvSpPr>
-        <p:spPr>
-          <a:xfrm>
-            <a:off x="804672" y="2066544"/>
-            <a:ext cx="548640" cy="548640"/>
-          </a:xfrm>
-          <a:prstGeom prst="ellipse">
-            <a:avLst/>
-          </a:prstGeom>
-          <a:solidFill>
-            <a:schemeClr val="accent1"/>
-          </a:solidFill>
-          <a:ln/>
-        </p:spPr>
-      </p:sp>
-      <p:pic>
-        <p:nvPicPr>
-          <p:cNvPr id="6" name="Image 0" descr="проблема">    </p:cNvPr>
-          <p:cNvPicPr>
-            <a:picLocks noChangeAspect="1"/>
-          </p:cNvPicPr>
-          <p:nvPr/>
-        </p:nvPicPr>
-        <p:blipFill>
-          <a:blip r:embed="rId1"/>
-          <a:stretch>
-            <a:fillRect/>
-          </a:stretch>
-        </p:blipFill>
-        <p:spPr>
-          <a:xfrm>
-            <a:off x="919886" y="2181758"/>
-            <a:ext cx="318211" cy="318211"/>
-          </a:xfrm>
-          <a:prstGeom prst="rect">
-            <a:avLst/>
-          </a:prstGeom>
-        </p:spPr>
-      </p:pic>
-      <p:sp>
-        <p:nvSpPr>
-          <p:cNvPr id="7" name="Text 4"/>
-          <p:cNvSpPr txBox="1"/>
-          <p:nvPr/>
-        </p:nvSpPr>
-        <p:spPr>
-          <a:xfrm>
-            <a:off x="1554480" y="2029968"/>
-            <a:ext cx="4175608" cy="896112"/>
-          </a:xfrm>
-          <a:prstGeom prst="rect">
-            <a:avLst/>
-          </a:prstGeom>
-          <a:noFill/>
-          <a:ln/>
-        </p:spPr>
-        <p:txBody>
-          <a:bodyPr wrap="square" lIns="0" tIns="0" rIns="0" bIns="0" rtlCol="0" anchor="t"/>
-          <a:lstStyle/>
-          <a:p>
-            <a:pPr indent="0" marL="0">
-              <a:buNone/>
-            </a:pPr>
-            <a:r>
-              <a:rPr lang="ru-RU" sz="1700" b="1" dirty="0">
-                <a:solidFill>
-                  <a:schemeClr val="tx1"/>
-                </a:solidFill>
-              </a:rPr>
-              <a:t>Прошивка удаляет загрузочную запись с адресом сервера — ещё до загрузки, не сделав ни одного запроса</a:t>
-            </a:r>
-            <a:endParaRPr lang="ru-RU" sz="1700" dirty="0"/>
-          </a:p>
-        </p:txBody>
-      </p:sp>
-      <p:sp>
-        <p:nvSpPr>
-          <p:cNvPr id="8" name="Shape 5"/>
-          <p:cNvSpPr/>
-          <p:nvPr/>
-        </p:nvSpPr>
-        <p:spPr>
-          <a:xfrm>
-            <a:off x="804672" y="2999232"/>
-            <a:ext cx="548640" cy="548640"/>
-          </a:xfrm>
-          <a:prstGeom prst="ellipse">
-            <a:avLst/>
-          </a:prstGeom>
-          <a:solidFill>
-            <a:schemeClr val="accent5"/>
-          </a:solidFill>
-          <a:ln/>
-        </p:spPr>
-      </p:sp>
-      <p:pic>
-        <p:nvPicPr>
-          <p:cNvPr id="9" name="Image 1" descr="решение">    </p:cNvPr>
-          <p:cNvPicPr>
-            <a:picLocks noChangeAspect="1"/>
-          </p:cNvPicPr>
-          <p:nvPr/>
-        </p:nvPicPr>
-        <p:blipFill>
-          <a:blip r:embed="rId2"/>
-          <a:stretch>
-            <a:fillRect/>
-          </a:stretch>
-        </p:blipFill>
-        <p:spPr>
-          <a:xfrm>
-            <a:off x="919886" y="3114446"/>
-            <a:ext cx="318211" cy="318211"/>
-          </a:xfrm>
-          <a:prstGeom prst="rect">
-            <a:avLst/>
-          </a:prstGeom>
-        </p:spPr>
-      </p:pic>
-      <p:sp>
-        <p:nvSpPr>
-          <p:cNvPr id="10" name="Text 6"/>
-          <p:cNvSpPr txBox="1"/>
-          <p:nvPr/>
-        </p:nvSpPr>
-        <p:spPr>
-          <a:xfrm>
-            <a:off x="1554480" y="2999232"/>
-            <a:ext cx="4175608" cy="749808"/>
-          </a:xfrm>
-          <a:prstGeom prst="rect">
-            <a:avLst/>
-          </a:prstGeom>
-          <a:noFill/>
-          <a:ln/>
-        </p:spPr>
-        <p:txBody>
-          <a:bodyPr wrap="square" lIns="0" tIns="0" rIns="0" bIns="0" rtlCol="0" anchor="t"/>
-          <a:lstStyle/>
-          <a:p>
-            <a:pPr indent="0" marL="0">
-              <a:buNone/>
-            </a:pPr>
-            <a:r>
-              <a:rPr lang="ru-RU" sz="1600" dirty="0">
-                <a:solidFill>
-                  <a:schemeClr val="tx1"/>
-                </a:solidFill>
-              </a:rPr>
-              <a:t>iPXE на основном разделе EFI: затирание его не трогает</a:t>
-            </a:r>
-            <a:endParaRPr lang="ru-RU" sz="1600" dirty="0"/>
-          </a:p>
-        </p:txBody>
-      </p:sp>
-      <p:sp>
-        <p:nvSpPr>
-          <p:cNvPr id="11" name="Проблема 2"/>
-          <p:cNvSpPr/>
-          <p:nvPr/>
-        </p:nvSpPr>
-        <p:spPr>
-          <a:xfrm>
-            <a:off x="6233008" y="1810512"/>
-            <a:ext cx="5410048" cy="2029968"/>
-          </a:xfrm>
-          <a:prstGeom prst="roundRect">
-            <a:avLst>
-              <a:gd name="adj" fmla="val 6306"/>
-            </a:avLst>
-          </a:prstGeom>
-          <a:solidFill>
-            <a:schemeClr val="bg2"/>
-          </a:solidFill>
-          <a:ln/>
-        </p:spPr>
-      </p:sp>
-      <p:sp>
-        <p:nvSpPr>
-          <p:cNvPr id="12" name="Shape 8"/>
-          <p:cNvSpPr/>
-          <p:nvPr/>
-        </p:nvSpPr>
-        <p:spPr>
-          <a:xfrm>
-            <a:off x="6489040" y="2066544"/>
-            <a:ext cx="548640" cy="548640"/>
-          </a:xfrm>
-          <a:prstGeom prst="ellipse">
-            <a:avLst/>
-          </a:prstGeom>
-          <a:solidFill>
-            <a:schemeClr val="accent1"/>
-          </a:solidFill>
-          <a:ln/>
-        </p:spPr>
-      </p:sp>
-      <p:pic>
-        <p:nvPicPr>
-          <p:cNvPr id="13" name="Image 2" descr="проблема">    </p:cNvPr>
-          <p:cNvPicPr>
-            <a:picLocks noChangeAspect="1"/>
-          </p:cNvPicPr>
-          <p:nvPr/>
-        </p:nvPicPr>
-        <p:blipFill>
-          <a:blip r:embed="rId3"/>
-          <a:stretch>
-            <a:fillRect/>
-          </a:stretch>
-        </p:blipFill>
-        <p:spPr>
-          <a:xfrm>
-            <a:off x="6604254" y="2181758"/>
-            <a:ext cx="318211" cy="318211"/>
-          </a:xfrm>
-          <a:prstGeom prst="rect">
-            <a:avLst/>
-          </a:prstGeom>
-        </p:spPr>
-      </p:pic>
-      <p:sp>
-        <p:nvSpPr>
-          <p:cNvPr id="14" name="Text 9"/>
-          <p:cNvSpPr txBox="1"/>
-          <p:nvPr/>
-        </p:nvSpPr>
-        <p:spPr>
-          <a:xfrm>
-            <a:off x="7238848" y="2029968"/>
-            <a:ext cx="4175608" cy="896112"/>
-          </a:xfrm>
-          <a:prstGeom prst="rect">
-            <a:avLst/>
-          </a:prstGeom>
-          <a:noFill/>
-          <a:ln/>
-        </p:spPr>
-        <p:txBody>
-          <a:bodyPr wrap="square" lIns="0" tIns="0" rIns="0" bIns="0" rtlCol="0" anchor="t"/>
-          <a:lstStyle/>
-          <a:p>
-            <a:pPr indent="0" marL="0">
-              <a:buNone/>
-            </a:pPr>
-            <a:r>
-              <a:rPr lang="ru-RU" sz="1700" b="1" dirty="0">
-                <a:solidFill>
-                  <a:schemeClr val="tx1"/>
-                </a:solidFill>
-              </a:rPr>
-              <a:t>BootNext дважды загрузил старую систему: прошивка записала свою запись под нужным номером</a:t>
-            </a:r>
-            <a:endParaRPr lang="ru-RU" sz="1700" dirty="0"/>
-          </a:p>
-        </p:txBody>
-      </p:sp>
-      <p:sp>
-        <p:nvSpPr>
-          <p:cNvPr id="15" name="Shape 10"/>
-          <p:cNvSpPr/>
-          <p:nvPr/>
-        </p:nvSpPr>
-        <p:spPr>
-          <a:xfrm>
-            <a:off x="6489040" y="2999232"/>
-            <a:ext cx="548640" cy="548640"/>
-          </a:xfrm>
-          <a:prstGeom prst="ellipse">
-            <a:avLst/>
-          </a:prstGeom>
-          <a:solidFill>
-            <a:schemeClr val="accent5"/>
-          </a:solidFill>
-          <a:ln/>
-        </p:spPr>
-      </p:sp>
-      <p:pic>
-        <p:nvPicPr>
-          <p:cNvPr id="16" name="Image 3" descr="решение">    </p:cNvPr>
-          <p:cNvPicPr>
-            <a:picLocks noChangeAspect="1"/>
-          </p:cNvPicPr>
-          <p:nvPr/>
-        </p:nvPicPr>
-        <p:blipFill>
-          <a:blip r:embed="rId4"/>
-          <a:stretch>
-            <a:fillRect/>
-          </a:stretch>
-        </p:blipFill>
-        <p:spPr>
-          <a:xfrm>
-            <a:off x="6604254" y="3114446"/>
-            <a:ext cx="318211" cy="318211"/>
-          </a:xfrm>
-          <a:prstGeom prst="rect">
-            <a:avLst/>
-          </a:prstGeom>
-        </p:spPr>
-      </p:pic>
-      <p:sp>
-        <p:nvSpPr>
-          <p:cNvPr id="17" name="Text 11"/>
-          <p:cNvSpPr txBox="1"/>
-          <p:nvPr/>
-        </p:nvSpPr>
-        <p:spPr>
-          <a:xfrm>
-            <a:off x="7238848" y="2999232"/>
-            <a:ext cx="4175608" cy="749808"/>
-          </a:xfrm>
-          <a:prstGeom prst="rect">
-            <a:avLst/>
-          </a:prstGeom>
-          <a:noFill/>
-          <a:ln/>
-        </p:spPr>
-        <p:txBody>
-          <a:bodyPr wrap="square" lIns="0" tIns="0" rIns="0" bIns="0" rtlCol="0" anchor="t"/>
-          <a:lstStyle/>
-          <a:p>
-            <a:pPr indent="0" marL="0">
-              <a:buNone/>
-            </a:pPr>
-            <a:r>
-              <a:rPr lang="ru-RU" sz="1600" dirty="0">
-                <a:solidFill>
-                  <a:schemeClr val="tx1"/>
-                </a:solidFill>
-              </a:rPr>
-              <a:t>Одноразовая запись systemd-boot: от прошивки нужна только первая запись BootOrder</a:t>
-            </a:r>
-            <a:endParaRPr lang="ru-RU" sz="1600" dirty="0"/>
-          </a:p>
-        </p:txBody>
-      </p:sp>
-      <p:sp>
-        <p:nvSpPr>
-          <p:cNvPr id="18" name="Проблема 3"/>
-          <p:cNvSpPr/>
-          <p:nvPr/>
-        </p:nvSpPr>
-        <p:spPr>
-          <a:xfrm>
-            <a:off x="548640" y="4050792"/>
-            <a:ext cx="5410048" cy="2029968"/>
-          </a:xfrm>
-          <a:prstGeom prst="roundRect">
-            <a:avLst>
-              <a:gd name="adj" fmla="val 6306"/>
-            </a:avLst>
-          </a:prstGeom>
-          <a:solidFill>
-            <a:schemeClr val="bg2"/>
-          </a:solidFill>
-          <a:ln/>
-        </p:spPr>
-      </p:sp>
-      <p:sp>
-        <p:nvSpPr>
-          <p:cNvPr id="19" name="Shape 13"/>
-          <p:cNvSpPr/>
-          <p:nvPr/>
-        </p:nvSpPr>
-        <p:spPr>
-          <a:xfrm>
-            <a:off x="804672" y="4306824"/>
-            <a:ext cx="548640" cy="548640"/>
-          </a:xfrm>
-          <a:prstGeom prst="ellipse">
-            <a:avLst/>
-          </a:prstGeom>
-          <a:solidFill>
-            <a:schemeClr val="accent1"/>
-          </a:solidFill>
-          <a:ln/>
-        </p:spPr>
-      </p:sp>
-      <p:pic>
-        <p:nvPicPr>
-          <p:cNvPr id="20" name="Image 4" descr="проблема">    </p:cNvPr>
-          <p:cNvPicPr>
-            <a:picLocks noChangeAspect="1"/>
-          </p:cNvPicPr>
-          <p:nvPr/>
-        </p:nvPicPr>
-        <p:blipFill>
-          <a:blip r:embed="rId5"/>
-          <a:stretch>
-            <a:fillRect/>
-          </a:stretch>
-        </p:blipFill>
-        <p:spPr>
-          <a:xfrm>
-            <a:off x="919886" y="4422038"/>
-            <a:ext cx="318211" cy="318211"/>
-          </a:xfrm>
-          <a:prstGeom prst="rect">
-            <a:avLst/>
-          </a:prstGeom>
-        </p:spPr>
-      </p:pic>
-      <p:sp>
-        <p:nvSpPr>
-          <p:cNvPr id="21" name="Text 14"/>
-          <p:cNvSpPr txBox="1"/>
-          <p:nvPr/>
-        </p:nvSpPr>
-        <p:spPr>
-          <a:xfrm>
-            <a:off x="1554480" y="4270248"/>
-            <a:ext cx="4175608" cy="896112"/>
-          </a:xfrm>
-          <a:prstGeom prst="rect">
-            <a:avLst/>
-          </a:prstGeom>
-          <a:noFill/>
-          <a:ln/>
-        </p:spPr>
-        <p:txBody>
-          <a:bodyPr wrap="square" lIns="0" tIns="0" rIns="0" bIns="0" rtlCol="0" anchor="t"/>
-          <a:lstStyle/>
-          <a:p>
-            <a:pPr indent="0" marL="0">
-              <a:buNone/>
-            </a:pPr>
-            <a:r>
-              <a:rPr lang="ru-RU" sz="1700" b="1" dirty="0">
-                <a:solidFill>
-                  <a:schemeClr val="tx1"/>
-                </a:solidFill>
-              </a:rPr>
-              <a:t>Домашний роутер отвечал на первые DNS-запросы ошибкой</a:t>
-            </a:r>
-            <a:endParaRPr lang="ru-RU" sz="1700" dirty="0"/>
-          </a:p>
-        </p:txBody>
-      </p:sp>
-      <p:sp>
-        <p:nvSpPr>
-          <p:cNvPr id="22" name="Shape 15"/>
-          <p:cNvSpPr/>
-          <p:nvPr/>
-        </p:nvSpPr>
-        <p:spPr>
-          <a:xfrm>
-            <a:off x="804672" y="5239512"/>
-            <a:ext cx="548640" cy="548640"/>
-          </a:xfrm>
-          <a:prstGeom prst="ellipse">
-            <a:avLst/>
-          </a:prstGeom>
-          <a:solidFill>
-            <a:schemeClr val="accent5"/>
-          </a:solidFill>
-          <a:ln/>
-        </p:spPr>
-      </p:sp>
-      <p:pic>
-        <p:nvPicPr>
-          <p:cNvPr id="23" name="Image 5" descr="решение">    </p:cNvPr>
-          <p:cNvPicPr>
-            <a:picLocks noChangeAspect="1"/>
-          </p:cNvPicPr>
-          <p:nvPr/>
-        </p:nvPicPr>
-        <p:blipFill>
-          <a:blip r:embed="rId6"/>
-          <a:stretch>
-            <a:fillRect/>
-          </a:stretch>
-        </p:blipFill>
-        <p:spPr>
-          <a:xfrm>
-            <a:off x="919886" y="5354726"/>
-            <a:ext cx="318211" cy="318211"/>
-          </a:xfrm>
-          <a:prstGeom prst="rect">
-            <a:avLst/>
-          </a:prstGeom>
-        </p:spPr>
-      </p:pic>
-      <p:sp>
-        <p:nvSpPr>
-          <p:cNvPr id="24" name="Text 16"/>
-          <p:cNvSpPr txBox="1"/>
-          <p:nvPr/>
-        </p:nvSpPr>
-        <p:spPr>
-          <a:xfrm>
-            <a:off x="1554480" y="5239512"/>
-            <a:ext cx="4175608" cy="749808"/>
-          </a:xfrm>
-          <a:prstGeom prst="rect">
-            <a:avLst/>
-          </a:prstGeom>
-          <a:noFill/>
-          <a:ln/>
-        </p:spPr>
-        <p:txBody>
-          <a:bodyPr wrap="square" lIns="0" tIns="0" rIns="0" bIns="0" rtlCol="0" anchor="t"/>
-          <a:lstStyle/>
-          <a:p>
-            <a:pPr indent="0" marL="0">
-              <a:buNone/>
-            </a:pPr>
-            <a:r>
-              <a:rPr lang="ru-RU" sz="1600" dirty="0">
-                <a:solidFill>
-                  <a:schemeClr val="tx1"/>
-                </a:solidFill>
-              </a:rPr>
-              <a:t>Три повтора, затем DNS-серверы 1.1.1.1 и 8.8.8.8</a:t>
-            </a:r>
-            <a:endParaRPr lang="ru-RU" sz="1600" dirty="0"/>
-          </a:p>
-        </p:txBody>
-      </p:sp>
-      <p:sp>
-        <p:nvSpPr>
-          <p:cNvPr id="25" name="Проблема 4"/>
-          <p:cNvSpPr/>
-          <p:nvPr/>
-        </p:nvSpPr>
-        <p:spPr>
-          <a:xfrm>
-            <a:off x="6233008" y="4050792"/>
-            <a:ext cx="5410048" cy="2029968"/>
-          </a:xfrm>
-          <a:prstGeom prst="roundRect">
-            <a:avLst>
-              <a:gd name="adj" fmla="val 6306"/>
-            </a:avLst>
-          </a:prstGeom>
-          <a:solidFill>
-            <a:schemeClr val="bg2"/>
-          </a:solidFill>
-          <a:ln/>
-        </p:spPr>
-      </p:sp>
-      <p:sp>
-        <p:nvSpPr>
-          <p:cNvPr id="26" name="Shape 18"/>
-          <p:cNvSpPr/>
-          <p:nvPr/>
-        </p:nvSpPr>
-        <p:spPr>
-          <a:xfrm>
-            <a:off x="6489040" y="4306824"/>
-            <a:ext cx="548640" cy="548640"/>
-          </a:xfrm>
-          <a:prstGeom prst="ellipse">
-            <a:avLst/>
-          </a:prstGeom>
-          <a:solidFill>
-            <a:schemeClr val="accent1"/>
-          </a:solidFill>
-          <a:ln/>
-        </p:spPr>
-      </p:sp>
-      <p:pic>
-        <p:nvPicPr>
-          <p:cNvPr id="27" name="Image 6" descr="проблема">    </p:cNvPr>
-          <p:cNvPicPr>
-            <a:picLocks noChangeAspect="1"/>
-          </p:cNvPicPr>
-          <p:nvPr/>
-        </p:nvPicPr>
-        <p:blipFill>
-          <a:blip r:embed="rId7"/>
-          <a:stretch>
-            <a:fillRect/>
-          </a:stretch>
-        </p:blipFill>
-        <p:spPr>
-          <a:xfrm>
-            <a:off x="6604254" y="4422038"/>
-            <a:ext cx="318211" cy="318211"/>
-          </a:xfrm>
-          <a:prstGeom prst="rect">
-            <a:avLst/>
-          </a:prstGeom>
-        </p:spPr>
-      </p:pic>
-      <p:sp>
-        <p:nvSpPr>
-          <p:cNvPr id="28" name="Text 19"/>
-          <p:cNvSpPr txBox="1"/>
-          <p:nvPr/>
-        </p:nvSpPr>
-        <p:spPr>
-          <a:xfrm>
-            <a:off x="7238848" y="4270248"/>
-            <a:ext cx="4175608" cy="896112"/>
-          </a:xfrm>
-          <a:prstGeom prst="rect">
-            <a:avLst/>
-          </a:prstGeom>
-          <a:noFill/>
-          <a:ln/>
-        </p:spPr>
-        <p:txBody>
-          <a:bodyPr wrap="square" lIns="0" tIns="0" rIns="0" bIns="0" rtlCol="0" anchor="t"/>
-          <a:lstStyle/>
-          <a:p>
-            <a:pPr indent="0" marL="0">
-              <a:buNone/>
-            </a:pPr>
-            <a:r>
-              <a:rPr lang="ru-RU" sz="1700" b="1" dirty="0">
-                <a:solidFill>
-                  <a:schemeClr val="tx1"/>
-                </a:solidFill>
-              </a:rPr>
-              <a:t>После сброса старая SSH-сессия часами держала порт туннеля</a:t>
-            </a:r>
-            <a:endParaRPr lang="ru-RU" sz="1700" dirty="0"/>
-          </a:p>
-        </p:txBody>
-      </p:sp>
-      <p:sp>
-        <p:nvSpPr>
-          <p:cNvPr id="29" name="Shape 20"/>
-          <p:cNvSpPr/>
-          <p:nvPr/>
-        </p:nvSpPr>
-        <p:spPr>
-          <a:xfrm>
-            <a:off x="6489040" y="5239512"/>
-            <a:ext cx="548640" cy="548640"/>
-          </a:xfrm>
-          <a:prstGeom prst="ellipse">
-            <a:avLst/>
-          </a:prstGeom>
-          <a:solidFill>
-            <a:schemeClr val="accent5"/>
-          </a:solidFill>
-          <a:ln/>
-        </p:spPr>
-      </p:sp>
-      <p:pic>
-        <p:nvPicPr>
-          <p:cNvPr id="30" name="Image 7" descr="решение">    </p:cNvPr>
-          <p:cNvPicPr>
-            <a:picLocks noChangeAspect="1"/>
-          </p:cNvPicPr>
-          <p:nvPr/>
-        </p:nvPicPr>
-        <p:blipFill>
-          <a:blip r:embed="rId8"/>
-          <a:stretch>
-            <a:fillRect/>
-          </a:stretch>
-        </p:blipFill>
-        <p:spPr>
-          <a:xfrm>
-            <a:off x="6604254" y="5354726"/>
-            <a:ext cx="318211" cy="318211"/>
-          </a:xfrm>
-          <a:prstGeom prst="rect">
-            <a:avLst/>
-          </a:prstGeom>
-        </p:spPr>
-      </p:pic>
-      <p:sp>
-        <p:nvSpPr>
-          <p:cNvPr id="31" name="Text 21"/>
-          <p:cNvSpPr txBox="1"/>
-          <p:nvPr/>
-        </p:nvSpPr>
-        <p:spPr>
-          <a:xfrm>
-            <a:off x="7238848" y="5239512"/>
-            <a:ext cx="4175608" cy="749808"/>
-          </a:xfrm>
-          <a:prstGeom prst="rect">
-            <a:avLst/>
-          </a:prstGeom>
-          <a:noFill/>
-          <a:ln/>
-        </p:spPr>
-        <p:txBody>
-          <a:bodyPr wrap="square" lIns="0" tIns="0" rIns="0" bIns="0" rtlCol="0" anchor="t"/>
-          <a:lstStyle/>
-          <a:p>
-            <a:pPr indent="0" marL="0">
-              <a:buNone/>
-            </a:pPr>
-            <a:r>
-              <a:rPr lang="ru-RU" sz="1600" dirty="0">
-                <a:solidFill>
-                  <a:schemeClr val="tx1"/>
-                </a:solidFill>
-              </a:rPr>
-              <a:t>Туннель через Unix-сокет: новое подключение заменяет старое</a:t>
-            </a:r>
-            <a:endParaRPr lang="ru-RU" sz="1600" dirty="0"/>
-          </a:p>
-        </p:txBody>
-      </p:sp>
-      <p:sp>
-        <p:nvSpPr>
-          <p:cNvPr id="25" name="Slide Number Placeholder 0"/>
-          <p:cNvSpPr>
-            <a:spLocks noGrp="1"/>
-          </p:cNvSpPr>
-          <p:nvPr>
-            <p:ph type="sldNum" sz="quarter" idx="4294967295"/>
-          </p:nvPr>
-        </p:nvSpPr>
-        <p:spPr>
-          <a:xfrm>
-            <a:off x="11000232" y="6419088"/>
-            <a:ext cx="640080" cy="274320"/>
-          </a:xfrm>
-          <a:prstGeom prst="rect">
-            <a:avLst/>
-          </a:prstGeom>
-          <a:extLst>
-            <a:ext uri="{C572A759-6A51-4108-AA02-DFA0A04FC94B}">
-              <ma14:wrappingTextBoxFlag xmlns:ma14="http://schemas.microsoft.com/office/mac/drawingml/2011/main" val="0"/>
-            </a:ext>
-          </a:extLst>
-        </p:spPr>
-        <p:txBody>
-          <a:bodyPr/>
-          <a:lstStyle>
-            <a:lvl1pPr>
-              <a:defRPr sz="1100">
-                <a:solidFill>
-                  <a:srgbClr val="5F6673"/>
-                </a:solidFill>
-              </a:defRPr>
-            </a:lvl1pPr>
-          </a:lstStyle>
-          <a:p>
-            <a:pPr algn="r"/>
-            <a:fld id="{F7021451-1387-4CA6-816F-3879F97B5CBC}" type="slidenum">
-              <a:rPr b="0" lang="ru-RU"/>
-              <a:t>18</a:t>
-            </a:fld>
-            <a:endParaRPr lang="ru-RU"/>
-          </a:p>
-        </p:txBody>
-      </p:sp>
-    </p:spTree>
-  </p:cSld>
-  <p:clrMapOvr>
-    <a:masterClrMapping/>
-  </p:clrMapOvr>
-  <p:transition spd="fast">
-    <p:fade/>
-  </p:transition>
-</p:sld>
-</file>
-
 <file path=ppt/slides/slide19.xml><?xml version="1.0" encoding="utf-8"?>
 <p:sld xmlns:a="http://schemas.openxmlformats.org/drawingml/2006/main" xmlns:r="http://schemas.openxmlformats.org/officeDocument/2006/relationships" xmlns:p="http://schemas.openxmlformats.org/presentationml/2006/main">
   <p:cSld name="Slide 19">
@@ -14990,55 +14171,6 @@
               <a:t>Система снова на связи</a:t>
             </a:r>
             <a:endParaRPr lang="ru-RU" sz="1700" dirty="0"/>
-          </a:p>
-        </p:txBody>
-      </p:sp>
-      <p:sp>
-        <p:nvSpPr>
-          <p:cNvPr id="36" name="Text 33">
-            <a:hlinkClick r:id="rId3" tooltip="Куда ушли 165 секунд" action="ppaction://hlinksldjump"/>
-          </p:cNvPr>
-          <p:cNvSpPr/>
-          <p:nvPr/>
-        </p:nvSpPr>
-        <p:spPr>
-          <a:xfrm>
-            <a:off x="4572000" y="5833872"/>
-            <a:ext cx="4937760" cy="384048"/>
-          </a:xfrm>
-          <a:prstGeom prst="roundRect">
-            <a:avLst>
-              <a:gd name="adj" fmla="val 28571"/>
-            </a:avLst>
-          </a:prstGeom>
-          <a:solidFill>
-            <a:schemeClr val="bg1"/>
-          </a:solidFill>
-          <a:ln/>
-        </p:spPr>
-        <p:txBody>
-          <a:bodyPr wrap="square" lIns="177800" tIns="0" rIns="177800" bIns="0" rtlCol="0" anchor="ctr"/>
-          <a:lstStyle/>
-          <a:p>
-            <a:pPr algn="l" indent="0" marL="0">
-              <a:buNone/>
-            </a:pPr>
-            <a:r>
-              <a:rPr lang="ru-RU" sz="1400" b="1" u="sng" dirty="0">
-                <a:solidFill>
-                  <a:schemeClr val="tx2"/>
-                </a:solidFill>
-                <a:hlinkClick r:id="rId3" action="ppaction://hlinksldjump" tooltip="Куда ушли 165 секунд">
-                  <a:extLst>
-                    <a:ext uri="{A12FA001-AC4F-418D-AE19-62706E023703}">
-                      <ahyp:hlinkClr xmlns:ahyp="http://schemas.microsoft.com/office/drawing/2018/hyperlinkcolor" val="tx"/>
-                    </a:ext>
-                  </a:extLst>
-                </a:hlinkClick>
-              </a:rPr>
-              <a:t>Если сеть подведёт — запись прогона, слайд 17  →</a:t>
-            </a:r>
-            <a:endParaRPr lang="ru-RU" sz="1400" dirty="0"/>
           </a:p>
         </p:txBody>
       </p:sp>
@@ -16041,7 +15173,7 @@
       </p:sp>
       <p:sp>
         <p:nvSpPr>
-          <p:cNvPr id="16" name="Цепочка не подписана: кто управляет сервером, тот управляет и восстановлением"/>
+          <p:cNvPr id="26" name="Нет удалённого питания: зависание в меню прошивки не поднять"/>
           <p:cNvSpPr/>
           <p:nvPr/>
         </p:nvSpPr>
@@ -16063,7 +15195,7 @@
       </p:sp>
       <p:sp>
         <p:nvSpPr>
-          <p:cNvPr id="17" name="Text 15"/>
+          <p:cNvPr id="27" name="Text 25"/>
           <p:cNvSpPr txBox="1"/>
           <p:nvPr/>
         </p:nvSpPr>
@@ -16091,7 +15223,7 @@
                   <a:schemeClr val="tx1"/>
                 </a:solidFill>
               </a:rPr>
-              <a:t>Цепочка не подписана: кто управляет сервером, тот управляет и восстановлением</a:t>
+              <a:t>Нет удалённого питания: зависание в меню прошивки не поднять</a:t>
             </a:r>
             <a:endParaRPr lang="ru-RU" sz="1500" dirty="0"/>
           </a:p>
@@ -16099,7 +15231,7 @@
       </p:sp>
       <p:sp>
         <p:nvSpPr>
-          <p:cNvPr id="18" name="Shape 16"/>
+          <p:cNvPr id="28" name="Shape 26"/>
           <p:cNvSpPr/>
           <p:nvPr/>
         </p:nvSpPr>
@@ -16119,7 +15251,7 @@
       </p:sp>
       <p:sp>
         <p:nvSpPr>
-          <p:cNvPr id="19" name="Подписать iPXE, UKI и образы, включить Secure Boot"/>
+          <p:cNvPr id="29" name="IP-KVM или умная розетка и «включаться при подаче питания»"/>
           <p:cNvSpPr/>
           <p:nvPr/>
         </p:nvSpPr>
@@ -16143,7 +15275,7 @@
       </p:sp>
       <p:sp>
         <p:nvSpPr>
-          <p:cNvPr id="20" name="Text 18"/>
+          <p:cNvPr id="30" name="Text 28"/>
           <p:cNvSpPr txBox="1"/>
           <p:nvPr/>
         </p:nvSpPr>
@@ -16171,7 +15303,7 @@
                   <a:schemeClr val="tx1"/>
                 </a:solidFill>
               </a:rPr>
-              <a:t>Подписать iPXE, UKI и образы, включить Secure Boot</a:t>
+              <a:t>IP-KVM или умная розетка и «включаться при подаче питания»</a:t>
             </a:r>
             <a:endParaRPr lang="ru-RU" sz="1500" dirty="0"/>
           </a:p>
@@ -16179,7 +15311,7 @@
       </p:sp>
       <p:sp>
         <p:nvSpPr>
-          <p:cNvPr id="21" name="57 % простоя — две загрузки машины"/>
+          <p:cNvPr id="31" name="4 полных прогона — ещё не статистика"/>
           <p:cNvSpPr/>
           <p:nvPr/>
         </p:nvSpPr>
@@ -16201,7 +15333,7 @@
       </p:sp>
       <p:sp>
         <p:nvSpPr>
-          <p:cNvPr id="22" name="Text 20"/>
+          <p:cNvPr id="32" name="Text 30"/>
           <p:cNvSpPr txBox="1"/>
           <p:nvPr/>
         </p:nvSpPr>
@@ -16229,7 +15361,7 @@
                   <a:schemeClr val="tx1"/>
                 </a:solidFill>
               </a:rPr>
-              <a:t>57 % простоя — две загрузки машины</a:t>
+              <a:t>4 полных прогона — ещё не статистика</a:t>
             </a:r>
             <a:endParaRPr lang="ru-RU" sz="1500" dirty="0"/>
           </a:p>
@@ -16237,7 +15369,7 @@
       </p:sp>
       <p:sp>
         <p:nvSpPr>
-          <p:cNvPr id="23" name="Shape 21"/>
+          <p:cNvPr id="33" name="Shape 31"/>
           <p:cNvSpPr/>
           <p:nvPr/>
         </p:nvSpPr>
@@ -16257,7 +15389,7 @@
       </p:sp>
       <p:sp>
         <p:nvSpPr>
-          <p:cNvPr id="24" name="Меньший UKI, kexec вместо второго прохода прошивки, гигабитная сеть"/>
+          <p:cNvPr id="34" name="Серия из 10+ прогонов: scripts/run-series.sh"/>
           <p:cNvSpPr/>
           <p:nvPr/>
         </p:nvSpPr>
@@ -16281,7 +15413,7 @@
       </p:sp>
       <p:sp>
         <p:nvSpPr>
-          <p:cNvPr id="25" name="Text 23"/>
+          <p:cNvPr id="35" name="Text 33"/>
           <p:cNvSpPr txBox="1"/>
           <p:nvPr/>
         </p:nvSpPr>
@@ -16309,330 +15441,9 @@
                   <a:schemeClr val="tx1"/>
                 </a:solidFill>
               </a:rPr>
-              <a:t>Меньший UKI, kexec вместо второго прохода прошивки, гигабитная сеть</a:t>
+              <a:t>Серия из 10+ прогонов: scripts/run-series.sh</a:t>
             </a:r>
             <a:endParaRPr lang="ru-RU" sz="1500" dirty="0"/>
-          </a:p>
-        </p:txBody>
-      </p:sp>
-      <p:sp>
-        <p:nvSpPr>
-          <p:cNvPr id="26" name="Нет удалённого питания: зависание в меню прошивки не поднять"/>
-          <p:cNvSpPr/>
-          <p:nvPr/>
-        </p:nvSpPr>
-        <p:spPr>
-          <a:xfrm>
-            <a:off x="548640" y="4736592"/>
-            <a:ext cx="5120640" cy="603504"/>
-          </a:xfrm>
-          <a:prstGeom prst="roundRect">
-            <a:avLst>
-              <a:gd name="adj" fmla="val 15152"/>
-            </a:avLst>
-          </a:prstGeom>
-          <a:solidFill>
-            <a:schemeClr val="bg2"/>
-          </a:solidFill>
-          <a:ln/>
-        </p:spPr>
-      </p:sp>
-      <p:sp>
-        <p:nvSpPr>
-          <p:cNvPr id="27" name="Text 25"/>
-          <p:cNvSpPr txBox="1"/>
-          <p:nvPr/>
-        </p:nvSpPr>
-        <p:spPr>
-          <a:xfrm>
-            <a:off x="731520" y="4736592"/>
-            <a:ext cx="4800600" cy="603504"/>
-          </a:xfrm>
-          <a:prstGeom prst="rect">
-            <a:avLst/>
-          </a:prstGeom>
-          <a:noFill/>
-          <a:ln/>
-        </p:spPr>
-        <p:txBody>
-          <a:bodyPr wrap="square" lIns="0" tIns="0" rIns="0" bIns="0" rtlCol="0" anchor="ctr"/>
-          <a:lstStyle/>
-          <a:p>
-            <a:pPr indent="0" marL="0">
-              <a:buNone/>
-            </a:pPr>
-            <a:r>
-              <a:rPr lang="ru-RU" sz="1500" dirty="0">
-                <a:solidFill>
-                  <a:schemeClr val="tx1"/>
-                </a:solidFill>
-              </a:rPr>
-              <a:t>Нет удалённого питания: зависание в меню прошивки не поднять</a:t>
-            </a:r>
-            <a:endParaRPr lang="ru-RU" sz="1500" dirty="0"/>
-          </a:p>
-        </p:txBody>
-      </p:sp>
-      <p:sp>
-        <p:nvSpPr>
-          <p:cNvPr id="28" name="Shape 26"/>
-          <p:cNvSpPr/>
-          <p:nvPr/>
-        </p:nvSpPr>
-        <p:spPr>
-          <a:xfrm>
-            <a:off x="5779008" y="4919472"/>
-            <a:ext cx="457200" cy="237744"/>
-          </a:xfrm>
-          <a:prstGeom prst="rightArrow">
-            <a:avLst/>
-          </a:prstGeom>
-          <a:solidFill>
-            <a:schemeClr val="accent4"/>
-          </a:solidFill>
-          <a:ln/>
-        </p:spPr>
-      </p:sp>
-      <p:sp>
-        <p:nvSpPr>
-          <p:cNvPr id="29" name="IP-KVM или умная розетка и «включаться при подаче питания»"/>
-          <p:cNvSpPr/>
-          <p:nvPr/>
-        </p:nvSpPr>
-        <p:spPr>
-          <a:xfrm>
-            <a:off x="6400800" y="4736592"/>
-            <a:ext cx="5239512" cy="603504"/>
-          </a:xfrm>
-          <a:prstGeom prst="roundRect">
-            <a:avLst>
-              <a:gd name="adj" fmla="val 15152"/>
-            </a:avLst>
-          </a:prstGeom>
-          <a:solidFill>
-            <a:schemeClr val="accent3">
-              <a:alpha val="18000"/>
-            </a:schemeClr>
-          </a:solidFill>
-          <a:ln/>
-        </p:spPr>
-      </p:sp>
-      <p:sp>
-        <p:nvSpPr>
-          <p:cNvPr id="30" name="Text 28"/>
-          <p:cNvSpPr txBox="1"/>
-          <p:nvPr/>
-        </p:nvSpPr>
-        <p:spPr>
-          <a:xfrm>
-            <a:off x="6583680" y="4736592"/>
-            <a:ext cx="4919472" cy="603504"/>
-          </a:xfrm>
-          <a:prstGeom prst="rect">
-            <a:avLst/>
-          </a:prstGeom>
-          <a:noFill/>
-          <a:ln/>
-        </p:spPr>
-        <p:txBody>
-          <a:bodyPr wrap="square" lIns="0" tIns="0" rIns="0" bIns="0" rtlCol="0" anchor="ctr"/>
-          <a:lstStyle/>
-          <a:p>
-            <a:pPr indent="0" marL="0">
-              <a:buNone/>
-            </a:pPr>
-            <a:r>
-              <a:rPr lang="ru-RU" sz="1500" dirty="0">
-                <a:solidFill>
-                  <a:schemeClr val="tx1"/>
-                </a:solidFill>
-              </a:rPr>
-              <a:t>IP-KVM или умная розетка и «включаться при подаче питания»</a:t>
-            </a:r>
-            <a:endParaRPr lang="ru-RU" sz="1500" dirty="0"/>
-          </a:p>
-        </p:txBody>
-      </p:sp>
-      <p:sp>
-        <p:nvSpPr>
-          <p:cNvPr id="31" name="4 полных прогона — ещё не статистика"/>
-          <p:cNvSpPr/>
-          <p:nvPr/>
-        </p:nvSpPr>
-        <p:spPr>
-          <a:xfrm>
-            <a:off x="548640" y="5440680"/>
-            <a:ext cx="5120640" cy="603504"/>
-          </a:xfrm>
-          <a:prstGeom prst="roundRect">
-            <a:avLst>
-              <a:gd name="adj" fmla="val 15152"/>
-            </a:avLst>
-          </a:prstGeom>
-          <a:solidFill>
-            <a:schemeClr val="bg2"/>
-          </a:solidFill>
-          <a:ln/>
-        </p:spPr>
-      </p:sp>
-      <p:sp>
-        <p:nvSpPr>
-          <p:cNvPr id="32" name="Text 30"/>
-          <p:cNvSpPr txBox="1"/>
-          <p:nvPr/>
-        </p:nvSpPr>
-        <p:spPr>
-          <a:xfrm>
-            <a:off x="731520" y="5440680"/>
-            <a:ext cx="4800600" cy="603504"/>
-          </a:xfrm>
-          <a:prstGeom prst="rect">
-            <a:avLst/>
-          </a:prstGeom>
-          <a:noFill/>
-          <a:ln/>
-        </p:spPr>
-        <p:txBody>
-          <a:bodyPr wrap="square" lIns="0" tIns="0" rIns="0" bIns="0" rtlCol="0" anchor="ctr"/>
-          <a:lstStyle/>
-          <a:p>
-            <a:pPr indent="0" marL="0">
-              <a:buNone/>
-            </a:pPr>
-            <a:r>
-              <a:rPr lang="ru-RU" sz="1500" dirty="0">
-                <a:solidFill>
-                  <a:schemeClr val="tx1"/>
-                </a:solidFill>
-              </a:rPr>
-              <a:t>4 полных прогона — ещё не статистика</a:t>
-            </a:r>
-            <a:endParaRPr lang="ru-RU" sz="1500" dirty="0"/>
-          </a:p>
-        </p:txBody>
-      </p:sp>
-      <p:sp>
-        <p:nvSpPr>
-          <p:cNvPr id="33" name="Shape 31"/>
-          <p:cNvSpPr/>
-          <p:nvPr/>
-        </p:nvSpPr>
-        <p:spPr>
-          <a:xfrm>
-            <a:off x="5779008" y="5623560"/>
-            <a:ext cx="457200" cy="237744"/>
-          </a:xfrm>
-          <a:prstGeom prst="rightArrow">
-            <a:avLst/>
-          </a:prstGeom>
-          <a:solidFill>
-            <a:schemeClr val="accent4"/>
-          </a:solidFill>
-          <a:ln/>
-        </p:spPr>
-      </p:sp>
-      <p:sp>
-        <p:nvSpPr>
-          <p:cNvPr id="34" name="Серия из 10+ прогонов: scripts/run-series.sh"/>
-          <p:cNvSpPr/>
-          <p:nvPr/>
-        </p:nvSpPr>
-        <p:spPr>
-          <a:xfrm>
-            <a:off x="6400800" y="5440680"/>
-            <a:ext cx="5239512" cy="603504"/>
-          </a:xfrm>
-          <a:prstGeom prst="roundRect">
-            <a:avLst>
-              <a:gd name="adj" fmla="val 15152"/>
-            </a:avLst>
-          </a:prstGeom>
-          <a:solidFill>
-            <a:schemeClr val="accent3">
-              <a:alpha val="18000"/>
-            </a:schemeClr>
-          </a:solidFill>
-          <a:ln/>
-        </p:spPr>
-      </p:sp>
-      <p:sp>
-        <p:nvSpPr>
-          <p:cNvPr id="35" name="Text 33"/>
-          <p:cNvSpPr txBox="1"/>
-          <p:nvPr/>
-        </p:nvSpPr>
-        <p:spPr>
-          <a:xfrm>
-            <a:off x="6583680" y="5440680"/>
-            <a:ext cx="4919472" cy="603504"/>
-          </a:xfrm>
-          <a:prstGeom prst="rect">
-            <a:avLst/>
-          </a:prstGeom>
-          <a:noFill/>
-          <a:ln/>
-        </p:spPr>
-        <p:txBody>
-          <a:bodyPr wrap="square" lIns="0" tIns="0" rIns="0" bIns="0" rtlCol="0" anchor="ctr"/>
-          <a:lstStyle/>
-          <a:p>
-            <a:pPr indent="0" marL="0">
-              <a:buNone/>
-            </a:pPr>
-            <a:r>
-              <a:rPr lang="ru-RU" sz="1500" dirty="0">
-                <a:solidFill>
-                  <a:schemeClr val="tx1"/>
-                </a:solidFill>
-              </a:rPr>
-              <a:t>Серия из 10+ прогонов: scripts/run-series.sh</a:t>
-            </a:r>
-            <a:endParaRPr lang="ru-RU" sz="1500" dirty="0"/>
-          </a:p>
-        </p:txBody>
-      </p:sp>
-      <p:sp>
-        <p:nvSpPr>
-          <p:cNvPr id="25" name="Slide Number Placeholder 0"/>
-          <p:cNvSpPr>
-            <a:spLocks noGrp="1"/>
-          </p:cNvSpPr>
-          <p:nvPr>
-            <p:ph type="sldNum" sz="quarter" idx="4294967295"/>
-          </p:nvPr>
-        </p:nvSpPr>
-        <p:spPr>
-          <a:xfrm>
-            <a:off x="11000232" y="6419088"/>
-            <a:ext cx="640080" cy="274320"/>
-          </a:xfrm>
-          <a:prstGeom prst="rect">
-            <a:avLst/>
-          </a:prstGeom>
-          <a:extLst>
-            <a:ext uri="{C572A759-6A51-4108-AA02-DFA0A04FC94B}">
-              <ma14:wrappingTextBoxFlag xmlns:ma14="http://schemas.microsoft.com/office/mac/drawingml/2011/main" val="0"/>
-            </a:ext>
-          </a:extLst>
-        </p:spPr>
-        <p:txBody>
-          <a:bodyPr/>
-          <a:lstStyle>
-            <a:lvl1pPr>
-              <a:defRPr sz="1100">
-                <a:solidFill>
-                  <a:srgbClr val="5F6673"/>
-                </a:solidFill>
-              </a:defRPr>
-            </a:lvl1pPr>
-          </a:lstStyle>
-          <a:p>
-            <a:pPr algn="r"/>
-            <a:fld id="{F7021451-1387-4CA6-816F-3879F97B5CBC}" type="slidenum">
-              <a:rPr b="0" lang="ru-RU"/>
-              <a:t>20</a:t>
-            </a:fld>
-            <a:endParaRPr lang="ru-RU"/>
           </a:p>
         </p:txBody>
       </p:sp>

</xml_diff>

<commit_message>
presentation: paper QR on the questions slide, answers for the retry chain, review without the source count
</commit_message>
<xml_diff>
--- a/presentation/OSreboot.pptx
+++ b/presentation/OSreboot.pptx
@@ -2188,7 +2188,7 @@
           <a:p/>
           <a:p>
             <a:r>
-              <a:t>• Слева QR-коды: репозиторий и страница состояния.</a:t>
+              <a:t>• Слева QR-коды: репозиторий, страница состояния и статья (paper.epsti.site).</a:t>
             </a:r>
           </a:p>
           <a:p>
@@ -2213,12 +2213,12 @@
           </a:p>
           <a:p>
             <a:r>
-              <a:t>• Что если VPS недоступен? — iPXE не скачает boot.ipxe и через 60 с перезагрузит машину; одноразовая запись уже израсходована, поэтому загрузится основная система.</a:t>
-            </a:r>
-          </a:p>
-          <a:p>
-            <a:r>
-              <a:t>• Почему не BootNext? — прошивка дважды подменила запись; одноразовая запись systemd-boot надёжнее.</a:t>
+              <a:t>• Что если VPS недоступен? — iPXE покажет ошибку и через 10 с начнёт заново, пока сервер не ответит; запись iPXE по умолчанию остаётся, поэтому и после отключения питания машина снова попадёт в iPXE.</a:t>
+            </a:r>
+          </a:p>
+          <a:p>
+            <a:r>
+              <a:t>• Почему не BootNext? — прошивка дважды подменила запись; надёжнее, когда systemd-boot запускает iPXE по записи по умолчанию.</a:t>
             </a:r>
           </a:p>
           <a:p>
@@ -2775,7 +2775,7 @@
               <a:rPr lang="ru-RU" dirty="0"/>
               <a:t>ВРЕМЯ: 0:40 · по плану закончить к 2:35
 ГЛАВНОЕ: каждое готовое решение закрывает задачу только частично. Слайд можно пропустить, если не хватает времени.
-• «Я разобрал 82 источника. Производители — Dell, HP, Apple — восстанавливают только свою ОС со своих серверов. Дата-центр — MAAS, Ironic — нужны BMC и своя сеть. Образы дисков — Clonezilla — запускает человек. Обновления с откатом не переживают стирания диска».
+• «Я посмотрел, что уже есть. Производители — Dell, HP, Apple — восстанавливают только свою ОС со своих серверов. Дата-центр — MAAS, Ironic — нужны BMC и своя сеть. Образы дисков — Clonezilla — запускает человек. Обновления с откатом не переживают стирания диска».
 • «И никто не меряет простой».
 • Честно: «У OSreboot в первом столбце тоже половинка: восстановление запускает команда затирания, а не сама поломка. Вернусь к этому в ограничениях».
 ЕСЛИ СПРОСЯТ «Dell BIOSConnect делает то же самое?» — «Только Windows, только со своих серверов, код закрыт, простой не меряет».
@@ -16019,7 +16019,7 @@
         <p:spPr>
           <a:xfrm>
             <a:off x="548640" y="1874520"/>
-            <a:ext cx="2880360" cy="3794760"/>
+            <a:ext cx="2286000" cy="3383280"/>
           </a:xfrm>
           <a:prstGeom prst="roundRect">
             <a:avLst>
@@ -16050,8 +16050,8 @@
         </p:blipFill>
         <p:spPr>
           <a:xfrm>
-            <a:off x="896112" y="2103120"/>
-            <a:ext cx="2194560" cy="2194560"/>
+            <a:off x="731520" y="2103120"/>
+            <a:ext cx="1920240" cy="1920240"/>
           </a:xfrm>
           <a:prstGeom prst="rect">
             <a:avLst/>
@@ -16066,8 +16066,8 @@
         </p:nvSpPr>
         <p:spPr>
           <a:xfrm>
-            <a:off x="685800" y="4462272"/>
-            <a:ext cx="2606040" cy="365760"/>
+            <a:off x="594360" y="4206240"/>
+            <a:ext cx="2194560" cy="365760"/>
           </a:xfrm>
           <a:prstGeom prst="rect">
             <a:avLst/>
@@ -16102,8 +16102,8 @@
         </p:nvSpPr>
         <p:spPr>
           <a:xfrm>
-            <a:off x="685800" y="4846320"/>
-            <a:ext cx="2606040" cy="548640"/>
+            <a:off x="594360" y="4572000"/>
+            <a:ext cx="2194560" cy="457200"/>
           </a:xfrm>
           <a:prstGeom prst="rect">
             <a:avLst/>
@@ -16119,14 +16119,14 @@
               <a:buNone/>
             </a:pPr>
             <a:r>
-              <a:rPr lang="ru-RU" sz="1400" dirty="0">
+              <a:rPr lang="ru-RU" sz="1300" dirty="0">
                 <a:solidFill>
                   <a:schemeClr val="accent4"/>
                 </a:solidFill>
               </a:rPr>
               <a:t>github.com/Irenid/OSreboot</a:t>
             </a:r>
-            <a:endParaRPr lang="ru-RU" sz="1400" dirty="0"/>
+            <a:endParaRPr lang="ru-RU" sz="1300" dirty="0"/>
           </a:p>
         </p:txBody>
       </p:sp>
@@ -16138,8 +16138,8 @@
         </p:nvSpPr>
         <p:spPr>
           <a:xfrm>
-            <a:off x="3703320" y="1874520"/>
-            <a:ext cx="2880360" cy="3794760"/>
+            <a:off x="3108960" y="1874520"/>
+            <a:ext cx="2286000" cy="3383280"/>
           </a:xfrm>
           <a:prstGeom prst="roundRect">
             <a:avLst>
@@ -16170,8 +16170,8 @@
         </p:blipFill>
         <p:spPr>
           <a:xfrm>
-            <a:off x="4050792" y="2103120"/>
-            <a:ext cx="2194560" cy="2194560"/>
+            <a:off x="3291840" y="2103120"/>
+            <a:ext cx="1920240" cy="1920240"/>
           </a:xfrm>
           <a:prstGeom prst="rect">
             <a:avLst/>
@@ -16186,8 +16186,8 @@
         </p:nvSpPr>
         <p:spPr>
           <a:xfrm>
-            <a:off x="3840480" y="4462272"/>
-            <a:ext cx="2606040" cy="365760"/>
+            <a:off x="3154680" y="4206240"/>
+            <a:ext cx="2194560" cy="365760"/>
           </a:xfrm>
           <a:prstGeom prst="rect">
             <a:avLst/>
@@ -16222,8 +16222,8 @@
         </p:nvSpPr>
         <p:spPr>
           <a:xfrm>
-            <a:off x="3840480" y="4846320"/>
-            <a:ext cx="2606040" cy="548640"/>
+            <a:off x="3154680" y="4572000"/>
+            <a:ext cx="2194560" cy="457200"/>
           </a:xfrm>
           <a:prstGeom prst="rect">
             <a:avLst/>
@@ -16239,14 +16239,134 @@
               <a:buNone/>
             </a:pPr>
             <a:r>
-              <a:rPr lang="ru-RU" sz="1400" dirty="0">
+              <a:rPr lang="ru-RU" sz="1300" dirty="0">
                 <a:solidFill>
                   <a:schemeClr val="accent4"/>
                 </a:solidFill>
               </a:rPr>
               <a:t>osreboot.epsti.site</a:t>
             </a:r>
-            <a:endParaRPr lang="ru-RU" sz="1400" dirty="0"/>
+            <a:endParaRPr lang="ru-RU" sz="1300" dirty="0"/>
+          </a:p>
+        </p:txBody>
+      </p:sp>
+      <p:sp>
+        <p:nvSpPr>
+          <p:cNvPr id="26" name="Статья"/>
+          <p:cNvSpPr/>
+          <p:nvPr/>
+        </p:nvSpPr>
+        <p:spPr>
+          <a:xfrm>
+            <a:off x="5669280" y="1874520"/>
+            <a:ext cx="2286000" cy="3383280"/>
+          </a:xfrm>
+          <a:prstGeom prst="roundRect">
+            <a:avLst>
+              <a:gd name="adj" fmla="val 4444"/>
+            </a:avLst>
+          </a:prstGeom>
+          <a:solidFill>
+            <a:schemeClr val="bg1"/>
+          </a:solidFill>
+          <a:ln/>
+        </p:spPr>
+      </p:sp>
+      <p:pic>
+        <p:nvPicPr>
+          <p:cNvPr id="27" name="Image 2" descr="QR-код: paper.epsti.site">
+            <a:hlinkClick r:id="rId11" tooltip="Статья"/>
+          </p:cNvPr>
+          <p:cNvPicPr>
+            <a:picLocks noChangeAspect="1"/>
+          </p:cNvPicPr>
+          <p:nvPr/>
+        </p:nvPicPr>
+        <p:blipFill>
+          <a:blip r:embed="rId10"/>
+          <a:stretch>
+            <a:fillRect/>
+          </a:stretch>
+        </p:blipFill>
+        <p:spPr>
+          <a:xfrm>
+            <a:off x="5852160" y="2103120"/>
+            <a:ext cx="1920240" cy="1920240"/>
+          </a:xfrm>
+          <a:prstGeom prst="rect">
+            <a:avLst/>
+          </a:prstGeom>
+        </p:spPr>
+      </p:pic>
+      <p:sp>
+        <p:nvSpPr>
+          <p:cNvPr id="28" name="Text 12"/>
+          <p:cNvSpPr txBox="1"/>
+          <p:nvPr/>
+        </p:nvSpPr>
+        <p:spPr>
+          <a:xfrm>
+            <a:off x="5715000" y="4206240"/>
+            <a:ext cx="2194560" cy="365760"/>
+          </a:xfrm>
+          <a:prstGeom prst="rect">
+            <a:avLst/>
+          </a:prstGeom>
+          <a:noFill/>
+          <a:ln/>
+        </p:spPr>
+        <p:txBody>
+          <a:bodyPr wrap="square" lIns="0" tIns="0" rIns="0" bIns="0" rtlCol="0" anchor="t"/>
+          <a:lstStyle/>
+          <a:p>
+            <a:pPr algn="ctr" indent="0" marL="0">
+              <a:buNone/>
+            </a:pPr>
+            <a:r>
+              <a:rPr lang="ru-RU" sz="1700" b="1" dirty="0">
+                <a:solidFill>
+                  <a:schemeClr val="tx2"/>
+                </a:solidFill>
+              </a:rPr>
+              <a:t>Статья</a:t>
+            </a:r>
+            <a:endParaRPr lang="ru-RU" sz="1700" dirty="0"/>
+          </a:p>
+        </p:txBody>
+      </p:sp>
+      <p:sp>
+        <p:nvSpPr>
+          <p:cNvPr id="29" name="Text 13"/>
+          <p:cNvSpPr txBox="1"/>
+          <p:nvPr/>
+        </p:nvSpPr>
+        <p:spPr>
+          <a:xfrm>
+            <a:off x="5715000" y="4572000"/>
+            <a:ext cx="2194560" cy="457200"/>
+          </a:xfrm>
+          <a:prstGeom prst="rect">
+            <a:avLst/>
+          </a:prstGeom>
+          <a:noFill/>
+          <a:ln/>
+        </p:spPr>
+        <p:txBody>
+          <a:bodyPr wrap="square" lIns="0" tIns="0" rIns="0" bIns="0" rtlCol="0" anchor="t"/>
+          <a:lstStyle/>
+          <a:p>
+            <a:pPr algn="ctr" indent="0" marL="0">
+              <a:buNone/>
+            </a:pPr>
+            <a:r>
+              <a:rPr lang="ru-RU" sz="1300" dirty="0">
+                <a:solidFill>
+                  <a:schemeClr val="accent4"/>
+                </a:solidFill>
+              </a:rPr>
+              <a:t>paper.epsti.site</a:t>
+            </a:r>
+            <a:endParaRPr lang="ru-RU" sz="1300" dirty="0"/>
           </a:p>
         </p:txBody>
       </p:sp>
@@ -16258,8 +16378,8 @@
         </p:nvSpPr>
         <p:spPr>
           <a:xfrm>
-            <a:off x="7315200" y="1874520"/>
-            <a:ext cx="4297680" cy="274320"/>
+            <a:off x="8229600" y="1874520"/>
+            <a:ext cx="3410712" cy="274320"/>
           </a:xfrm>
           <a:prstGeom prst="rect">
             <a:avLst/>
@@ -16296,8 +16416,8 @@
         </p:nvSpPr>
         <p:spPr>
           <a:xfrm>
-            <a:off x="7315200" y="2286000"/>
-            <a:ext cx="4325112" cy="548640"/>
+            <a:off x="8229600" y="2286000"/>
+            <a:ext cx="3410712" cy="548640"/>
           </a:xfrm>
           <a:prstGeom prst="roundRect">
             <a:avLst>
@@ -16345,8 +16465,8 @@
         </p:nvSpPr>
         <p:spPr>
           <a:xfrm>
-            <a:off x="7315200" y="2971800"/>
-            <a:ext cx="4325112" cy="548640"/>
+            <a:off x="8229600" y="2971800"/>
+            <a:ext cx="3410712" cy="548640"/>
           </a:xfrm>
           <a:prstGeom prst="roundRect">
             <a:avLst>
@@ -16394,8 +16514,8 @@
         </p:nvSpPr>
         <p:spPr>
           <a:xfrm>
-            <a:off x="7315200" y="3657600"/>
-            <a:ext cx="4325112" cy="548640"/>
+            <a:off x="8229600" y="3657600"/>
+            <a:ext cx="3410712" cy="548640"/>
           </a:xfrm>
           <a:prstGeom prst="roundRect">
             <a:avLst>
@@ -16441,8 +16561,8 @@
         </p:nvSpPr>
         <p:spPr>
           <a:xfrm>
-            <a:off x="7315200" y="4572000"/>
-            <a:ext cx="4325112" cy="1097280"/>
+            <a:off x="8229600" y="4572000"/>
+            <a:ext cx="3410712" cy="1097280"/>
           </a:xfrm>
           <a:prstGeom prst="rect">
             <a:avLst/>
@@ -25867,7 +25987,7 @@
                   <a:schemeClr val="accent1"/>
                 </a:solidFill>
               </a:rPr>
-              <a:t>ОБЗОР · 82 ИСТОЧНИКА</a:t>
+              <a:t>ОБЗОР</a:t>
             </a:r>
             <a:endParaRPr lang="ru-RU" sz="1300" dirty="0"/>
           </a:p>
@@ -26472,7 +26592,7 @@
                   <a:schemeClr val="accent4"/>
                 </a:solidFill>
               </a:rPr>
-              <a:t>MAAS, Ironic, Tinkerbell</a:t>
+              <a:t>MAAS, Ironic</a:t>
             </a:r>
             <a:endParaRPr lang="ru-RU" sz="1200" dirty="0"/>
           </a:p>
@@ -26725,7 +26845,7 @@
                   <a:schemeClr val="accent4"/>
                 </a:solidFill>
               </a:rPr>
-              <a:t>Clonezilla, FOG, ReaR</a:t>
+              <a:t>Clonezilla</a:t>
             </a:r>
             <a:endParaRPr lang="ru-RU" sz="1200" dirty="0"/>
           </a:p>
@@ -26961,7 +27081,7 @@
                   <a:schemeClr val="accent4"/>
                 </a:solidFill>
               </a:rPr>
-              <a:t>RAUC, OSTree, Mender</a:t>
+              <a:t>A/B, systemd-boot</a:t>
             </a:r>
             <a:endParaRPr lang="ru-RU" sz="1200" dirty="0"/>
           </a:p>

</xml_diff>

<commit_message>
presentation: slides 7, 9, 14 and the demo notes follow the retry chain
</commit_message>
<xml_diff>
--- a/presentation/OSreboot.pptx
+++ b/presentation/OSreboot.pptx
@@ -1322,7 +1322,7 @@
 ГЛАВНОЕ: три вопроса — куда пишет, что пишет, что будет, если сломалось.
 • Куда: только два раздела с нужными метками, каждая ровно одна; тип, файловая система и размер до 4 и 128 GiB; раздел не смонтирован; сама работает из памяти.
 • Что: HTTPS с проверкой сертификата, SHA-256 до записи, чтение обратно после.
-• Если сломалось: iPXE перезагружает машину через 60 с, среда восстановления — через 20 минут, оставив вход по SSH; зависшее скачивание повторяется.
+• Если сломалось: нет сети — iPXE через 10 с начинает заново, а скачивание ждёт сеть и докачивает; отключили питание — после включения снова iPXE, пока восстановленная система не уберёт его запись; ошибка в среде восстановления — этап failed, вход по SSH, через 20 минут перезагрузка в основную систему.
 ПЕРЕД СЛЕДУЮЩИМ СЛАЙДОМ СПРОСИ: «Как думаете, сколько длится простой? Минута? Десять?» — и щёлкни.</a:t>
             </a:r>
             <a:endParaRPr lang="ru-RU" dirty="0"/>
@@ -1746,7 +1746,7 @@
           </a:p>
           <a:p>
             <a:r>
-              <a:t>0 — «Скрипт поставил одноразовую запись iPXE, остановил сигналы, затёр по 64 MiB и сбросил машину. Системы больше нет».</a:t>
+              <a:t>0 — «Скрипт поставил запись iPXE по умолчанию, остановил сигналы, затёр по 64 MiB и сбросил машину. Системы больше нет».</a:t>
             </a:r>
           </a:p>
           <a:p>
@@ -1796,7 +1796,7 @@
           </a:p>
           <a:p>
             <a:r>
-              <a:t>ЕСЛИ СЛОМАЛОСЬ: «Сработал предохранитель: через 60 секунд или 20 минут машина сама вернётся в свою систему».</a:t>
+              <a:t>ЕСЛИ ПРОПАЛА СЕТЬ: «iPXE повторяет каждые 10 секунд, а скачивание докачается, когда сеть вернётся». ЕСЛИ ОШИБКА В СРЕДЕ ВОССТАНОВЛЕНИЯ: «Сработал предохранитель: через 20 минут машина сама вернётся в свою систему».</a:t>
             </a:r>
           </a:p>
         </p:txBody>
@@ -2963,7 +2963,7 @@
 ГЛАВНОЕ: ни один вариант не подошёл, поэтому iPXE лежит на диске.
 • «А — нужен человек. Б — нужна своя сеть с DHCP- и TFTP-сервером рядом, в чужой аудитории её нет».
 • «В я очень хотел: UEFI HTTP Boot. Но прошивка этого ноутбука удалила мою загрузочную запись с адресом сервера при следующем включении — даже не обратившись к серверу. HTTPS она не умеет, а адрес берёт только у DHCP-сервера сети».
-• «Решение: iPXE — сетевой загрузчик с HTTPS — лежит на основном разделе EFI, который затирание не трогает. Его один раз запускает systemd-boot».
+• «Решение: iPXE — сетевой загрузчик с HTTPS — лежит на основном разделе EFI, который затирание не трогает. Его запускает systemd-boot, пока система не восстановится».
 ЕСЛИ СПРОСЯТ «А перепрошить BIOS?» — «Неудачная запись превращает ноутбук в кирпич, без программатора его не поднять. Отказался».
 ЕСЛИ СПРОСЯТ «iPXE на том же диске — не жульничество?» — «Стирается тестовая система, а iPXE играет роль BMC: он должен пережить поломку. Стирание всего диска — ограничение, оно в конце».
 ПЕРЕХОД: «Вот как это выглядит целиком».</a:t>
@@ -3151,11 +3151,11 @@
               <a:rPr lang="ru-RU" dirty="0"/>
               <a:t>ВРЕМЯ: 1:05 · по плану закончить к 5:25
 ГЛАВНОЕ: 4 фазы и 8 этапов. Эти же 8 названий будут на странице состояния во время демо.
-• 1. Стирание: osreboot-wipe сначала проверяет, что после сброса запустится iPXE, ставит одноразовую запись, затирает по 64 MiB в начале двух разделов и сбрасывает машину.
+• 1. Стирание: osreboot-wipe сначала проверяет, что после сброса запустится iPXE, делает запись iPXE записью по умолчанию (она переживёт и отключение питания), затирает по 64 MiB в начале двух разделов и сбрасывает машину.
 • 2–3. Сетевая загрузка, около 68 с: прошивка → systemd-boot → iPXE. Он получает адрес, находит сервер и по HTTPS качает среду восстановления. Доверяет только сертификатам Let’s Encrypt.
 • 4–7. В памяти, около 56 с: находит разделы по меткам, качает образы, проверяет SHA-256, пишет, читает обратно, ставит BootNext.
-• 8. Возврат, около 41 с: загрузка восстановленной системы, первый сигнал закрывает простой.
-ЕСЛИ СПРОСЯТ «Почему iPXE не через BootNext прошивки?» — «Прошивка Insyde дважды записала свою запись под нужным номером и загрузила старую систему. Одноразовая запись systemd-boot надёжнее: от прошивки нужна только первая запись BootOrder».
+• 8. Возврат, около 41 с: загрузка восстановленной системы; она убирает запись iPXE, а её первый сигнал закрывает простой.
+ЕСЛИ СПРОСЯТ «Почему iPXE не через BootNext прошивки?» — «Прошивка Insyde дважды записала свою запись под нужным номером и загрузила старую систему. Надёжнее, когда systemd-boot запускает iPXE по записи по умолчанию: от прошивки нужна только первая запись BootOrder».
 ЕСЛИ СПРОСЯТ «Что такое UKI?» — «Ядро, начальный образ и параметры в одном файле .efi; его можно запустить как обычную программу UEFI».
 ПЕРЕХОД: «А как сервер понимает, что ноутбук лёг и встал?»</a:t>
             </a:r>
@@ -10213,7 +10213,7 @@
                   <a:schemeClr val="tx1"/>
                 </a:solidFill>
               </a:rPr>
-              <a:t>Ошибка в iPXE — перезагрузка через 60 с</a:t>
+              <a:t>Нет сети или ошибка в iPXE — через 10 с всё заново</a:t>
             </a:r>
             <a:endParaRPr lang="ru-RU" sz="1600" dirty="0"/>
           </a:p>
@@ -10231,7 +10231,7 @@
                   <a:schemeClr val="tx1"/>
                 </a:solidFill>
               </a:rPr>
-              <a:t>Ошибка восстановления — этап failed, вход по SSH, перезагрузка через 20 мин</a:t>
+              <a:t>Обрыв при скачивании — ждёт сеть и докачивает</a:t>
             </a:r>
             <a:endParaRPr lang="ru-RU" sz="1600" dirty="0"/>
           </a:p>
@@ -10249,7 +10249,25 @@
                   <a:schemeClr val="tx1"/>
                 </a:solidFill>
               </a:rPr>
-              <a:t>Зависшее скачивание (меньше 1 KiB/s минуту) — повтор</a:t>
+              <a:t>Отключили питание — после включения снова iPXE</a:t>
+            </a:r>
+            <a:endParaRPr lang="ru-RU" sz="1600" dirty="0"/>
+          </a:p>
+          <a:p>
+            <a:pPr marL="228600" indent="-228600">
+              <a:spcAft>
+                <a:spcPts val="1000"/>
+              </a:spcAft>
+              <a:buSzPct val="100000"/>
+              <a:buChar char="•"/>
+            </a:pPr>
+            <a:r>
+              <a:rPr lang="ru-RU" sz="1600" dirty="0">
+                <a:solidFill>
+                  <a:schemeClr val="tx1"/>
+                </a:solidFill>
+              </a:rPr>
+              <a:t>Ошибка восстановления — этап failed, вход по SSH, перезагрузка через 20 мин</a:t>
             </a:r>
             <a:endParaRPr lang="ru-RU" sz="1600" dirty="0"/>
           </a:p>
@@ -28998,7 +29016,7 @@
                   <a:schemeClr val="tx1"/>
                 </a:solidFill>
               </a:rPr>
-              <a:t>iPXE — сетевой загрузчик с HTTPS — лежит на основном разделе EFI, который затирание не трогает. Его один раз запускает systemd-boot.</a:t>
+              <a:t>iPXE — сетевой загрузчик с HTTPS — лежит на основном разделе EFI, который затирание не трогает. Его запускает systemd-boot, пока система не восстановится.</a:t>
             </a:r>
             <a:endParaRPr lang="ru-RU" sz="1700" dirty="0"/>
           </a:p>
@@ -30949,7 +30967,7 @@
                   <a:schemeClr val="accent4"/>
                 </a:solidFill>
               </a:rPr>
-              <a:t>osreboot-wipe: проверки, одноразовая запись iPXE, по 64 MiB нулей, сброс</a:t>
+              <a:t>osreboot-wipe: проверки, запись iPXE по умолчанию, по 64 MiB нулей, сброс</a:t>
             </a:r>
             <a:endParaRPr lang="ru-RU" sz="1400" dirty="0"/>
           </a:p>

</xml_diff>